<commit_message>
fix: preserve spreadsheet and slide layout and speed offline preparation
</commit_message>
<xml_diff>
--- a/tests/fixtures/formatting.pptx
+++ b/tests/fixtures/formatting.pptx
@@ -959,6 +959,223 @@
           </a:p>
         </p:txBody>
       </p:sp>
+      <p:sp>
+        <p:nvSpPr>
+          <p:cNvPr id="3" name="Text 1"/>
+          <p:cNvSpPr/>
+          <p:nvPr/>
+        </p:nvSpPr>
+        <p:spPr>
+          <a:xfrm>
+            <a:off x="685800" y="1828800"/>
+            <a:ext cx="7315200" cy="731520"/>
+          </a:xfrm>
+          <a:prstGeom prst="rect">
+            <a:avLst/>
+          </a:prstGeom>
+          <a:noFill/>
+          <a:ln/>
+        </p:spPr>
+        <p:txBody>
+          <a:bodyPr wrap="square" rtlCol="0" anchor="ctr"/>
+          <a:lstStyle/>
+          <a:p>
+            <a:pPr algn="ctr" indent="0" marL="0">
+              <a:buNone/>
+            </a:pPr>
+            <a:r>
+              <a:rPr lang="en-US" sz="1200" dirty="0">
+                <a:solidFill>
+                  <a:srgbClr val="000000"/>
+                </a:solidFill>
+              </a:rPr>
+              <a:t>Small </a:t>
+            </a:r>
+            <a:pPr algn="ctr" indent="0" marL="0">
+              <a:buNone/>
+            </a:pPr>
+            <a:r>
+              <a:rPr lang="en-US" sz="3200" b="1" dirty="0">
+                <a:solidFill>
+                  <a:srgbClr val="000000"/>
+                </a:solidFill>
+              </a:rPr>
+              <a:t>LARGE</a:t>
+            </a:r>
+            <a:endParaRPr lang="en-US" sz="1200" dirty="0"/>
+          </a:p>
+        </p:txBody>
+      </p:sp>
+      <p:graphicFrame>
+        <p:nvGraphicFramePr>
+          <p:cNvPr id="2" name="Table 0"/>
+          <p:cNvGraphicFramePr>
+            <a:graphicFrameLocks noGrp="1"/>
+          </p:cNvGraphicFramePr>
+          <p:nvPr>
+            <p:extLst>
+              <p:ext uri="{D42A27DB-BD31-4B8C-83A1-F6EECF244321}">
+                <p14:modId xmlns:p14="http://schemas.microsoft.com/office/powerpoint/2010/main" val="1579011935"/>
+              </p:ext>
+            </p:extLst>
+          </p:nvPr>
+        </p:nvGraphicFramePr>
+        <p:xfrm>
+          <a:off x="685800" y="2926080"/>
+          <a:ext cx="5486400" cy="914400"/>
+        </p:xfrm>
+        <a:graphic>
+          <a:graphicData uri="http://schemas.openxmlformats.org/drawingml/2006/table">
+            <a:tbl>
+              <a:tblPr/>
+              <a:tblGrid>
+                <a:gridCol w="1828800"/>
+                <a:gridCol w="3657600"/>
+              </a:tblGrid>
+              <a:tr h="548640">
+                <a:tc>
+                  <a:txBody>
+                    <a:bodyPr/>
+                    <a:lstStyle/>
+                    <a:p>
+                      <a:pPr indent="0" marL="0">
+                        <a:buNone/>
+                      </a:pPr>
+                      <a:r>
+                        <a:rPr lang="en-US" sz="1400" b="1" dirty="0">
+                          <a:solidFill>
+                            <a:srgbClr val="000000"/>
+                          </a:solidFill>
+                        </a:rPr>
+                        <a:t>Short</a:t>
+                      </a:r>
+                      <a:endParaRPr lang="en-US" sz="1400" dirty="0"/>
+                    </a:p>
+                  </a:txBody>
+                  <a:tcPr marL="45720" marR="45720" marT="45720" marB="45720">
+                    <a:lnL w="0" cap="flat" cmpd="sng" algn="ctr">
+                      <a:noFill/>
+                    </a:lnL>
+                    <a:lnR w="0" cap="flat" cmpd="sng" algn="ctr">
+                      <a:noFill/>
+                    </a:lnR>
+                    <a:lnT w="0" cap="flat" cmpd="sng" algn="ctr">
+                      <a:noFill/>
+                    </a:lnT>
+                    <a:lnB w="0" cap="flat" cmpd="sng" algn="ctr">
+                      <a:noFill/>
+                    </a:lnB>
+                  </a:tcPr>
+                </a:tc>
+                <a:tc>
+                  <a:txBody>
+                    <a:bodyPr/>
+                    <a:lstStyle/>
+                    <a:p>
+                      <a:pPr indent="0" marL="0">
+                        <a:buNone/>
+                      </a:pPr>
+                      <a:r>
+                        <a:rPr lang="en-US" sz="1400" i="1" dirty="0">
+                          <a:solidFill>
+                            <a:srgbClr val="000000"/>
+                          </a:solidFill>
+                        </a:rPr>
+                        <a:t>Wider column</a:t>
+                      </a:r>
+                      <a:endParaRPr lang="en-US" sz="1400" dirty="0"/>
+                    </a:p>
+                  </a:txBody>
+                  <a:tcPr marL="45720" marR="45720" marT="45720" marB="45720">
+                    <a:lnL w="0" cap="flat" cmpd="sng" algn="ctr">
+                      <a:noFill/>
+                    </a:lnL>
+                    <a:lnR w="0" cap="flat" cmpd="sng" algn="ctr">
+                      <a:noFill/>
+                    </a:lnR>
+                    <a:lnT w="0" cap="flat" cmpd="sng" algn="ctr">
+                      <a:noFill/>
+                    </a:lnT>
+                    <a:lnB w="0" cap="flat" cmpd="sng" algn="ctr">
+                      <a:noFill/>
+                    </a:lnB>
+                  </a:tcPr>
+                </a:tc>
+              </a:tr>
+              <a:tr h="548640">
+                <a:tc>
+                  <a:txBody>
+                    <a:bodyPr/>
+                    <a:lstStyle/>
+                    <a:p>
+                      <a:pPr indent="0" marL="0">
+                        <a:buNone/>
+                      </a:pPr>
+                      <a:r>
+                        <a:rPr lang="en-US" sz="1400" dirty="0">
+                          <a:solidFill>
+                            <a:srgbClr val="000000"/>
+                          </a:solidFill>
+                        </a:rPr>
+                        <a:t>Row two</a:t>
+                      </a:r>
+                      <a:endParaRPr lang="en-US" sz="1400" dirty="0"/>
+                    </a:p>
+                  </a:txBody>
+                  <a:tcPr marL="45720" marR="45720" marT="45720" marB="45720">
+                    <a:lnL w="0" cap="flat" cmpd="sng" algn="ctr">
+                      <a:noFill/>
+                    </a:lnL>
+                    <a:lnR w="0" cap="flat" cmpd="sng" algn="ctr">
+                      <a:noFill/>
+                    </a:lnR>
+                    <a:lnT w="0" cap="flat" cmpd="sng" algn="ctr">
+                      <a:noFill/>
+                    </a:lnT>
+                    <a:lnB w="0" cap="flat" cmpd="sng" algn="ctr">
+                      <a:noFill/>
+                    </a:lnB>
+                  </a:tcPr>
+                </a:tc>
+                <a:tc>
+                  <a:txBody>
+                    <a:bodyPr/>
+                    <a:lstStyle/>
+                    <a:p>
+                      <a:pPr indent="0" marL="0">
+                        <a:buNone/>
+                      </a:pPr>
+                      <a:r>
+                        <a:rPr lang="en-US" sz="1400" dirty="0">
+                          <a:solidFill>
+                            <a:srgbClr val="000000"/>
+                          </a:solidFill>
+                        </a:rPr>
+                        <a:t>Underlined cell</a:t>
+                      </a:r>
+                      <a:endParaRPr lang="en-US" sz="1400" dirty="0"/>
+                    </a:p>
+                  </a:txBody>
+                  <a:tcPr marL="45720" marR="45720" marT="45720" marB="45720">
+                    <a:lnL w="0" cap="flat" cmpd="sng" algn="ctr">
+                      <a:noFill/>
+                    </a:lnL>
+                    <a:lnR w="0" cap="flat" cmpd="sng" algn="ctr">
+                      <a:noFill/>
+                    </a:lnR>
+                    <a:lnT w="0" cap="flat" cmpd="sng" algn="ctr">
+                      <a:noFill/>
+                    </a:lnT>
+                    <a:lnB w="0" cap="flat" cmpd="sng" algn="ctr">
+                      <a:noFill/>
+                    </a:lnB>
+                  </a:tcPr>
+                </a:tc>
+              </a:tr>
+            </a:tbl>
+          </a:graphicData>
+        </a:graphic>
+      </p:graphicFrame>
     </p:spTree>
   </p:cSld>
   <p:clrMapOvr>

</xml_diff>